<commit_message>
feat(sesion-06): performance lab con K6 + contenido enriquecido
- ci-lab/performance: target nginx en Docker + k6 smoke/load/fail + workflow qa-perf
- PPT_CONTENIDO.md: 20 slides con codigo real, tablas y datos verificados
- SESION_06.md: ejemplos con salidas reales, seccion p95/percentiles, mini-reto
- sesion-06.pptx regenerado acorde al nuevo contenido

Excluye GUIA_INSTRUCTOR.md (privada, gitignored).
</commit_message>
<xml_diff>
--- a/sesiones/sesion-06/sesion-06.pptx
+++ b/sesiones/sesion-06/sesion-06.pptx
@@ -3179,7 +3179,7 @@
                 </a:solidFill>
                 <a:latin typeface="Calibri"/>
               </a:rPr>
-              <a:t>Performance con K6</a:t>
+              <a:t>Performance con K6 — ¿el sistema aguanta?</a:t>
             </a:r>
           </a:p>
         </p:txBody>
@@ -3252,7 +3252,7 @@
                 </a:solidFill>
                 <a:latin typeface="Calibri"/>
               </a:rPr>
-              <a:t>• Sesión 6 · target local + Docker</a:t>
+              <a:t>• Sesión 6 de 10 · Curso QA Automation</a:t>
             </a:r>
           </a:p>
           <a:p>
@@ -3268,7 +3268,39 @@
                 </a:solidFill>
                 <a:latin typeface="Calibri"/>
               </a:rPr>
-              <a:t>• Frase: la performance también se verifica automáticamente</a:t>
+              <a:t>• De "¿devuelve lo correcto?" a "¿lo hace rápido y estable bajo carga?"</a:t>
+            </a:r>
+          </a:p>
+          <a:p>
+            <a:pPr>
+              <a:spcAft>
+                <a:spcPts val="1000"/>
+              </a:spcAft>
+            </a:pPr>
+            <a:r>
+              <a:rPr sz="1800" b="0">
+                <a:solidFill>
+                  <a:srgbClr val="2C3E50"/>
+                </a:solidFill>
+                <a:latin typeface="Calibri"/>
+              </a:rPr>
+              <a:t>• SUT: target local (nginx) en Docker — sin depender de internet</a:t>
+            </a:r>
+          </a:p>
+          <a:p>
+            <a:pPr>
+              <a:spcAft>
+                <a:spcPts val="1000"/>
+              </a:spcAft>
+            </a:pPr>
+            <a:r>
+              <a:rPr sz="1800" b="0">
+                <a:solidFill>
+                  <a:srgbClr val="2C3E50"/>
+                </a:solidFill>
+                <a:latin typeface="Calibri"/>
+              </a:rPr>
+              <a:t>• Cierre Reto 1: API (S3/S4) + CI (S5) + performance (hoy)</a:t>
             </a:r>
           </a:p>
         </p:txBody>
@@ -3398,7 +3430,7 @@
                 </a:solidFill>
                 <a:latin typeface="Calibri"/>
               </a:rPr>
-              <a:t>DEMO load</a:t>
+              <a:t>~10 VUs, ~40 s, ¿sigue rápido?</a:t>
             </a:r>
           </a:p>
         </p:txBody>
@@ -3471,7 +3503,23 @@
                 </a:solidFill>
                 <a:latin typeface="Calibri"/>
               </a:rPr>
-              <a:t>• Señala los thresholds en el resumen</a:t>
+              <a:t>• Resultado real: ✓ p(95)&lt;800 · checks 100% · vus_max 10 · exit 0</a:t>
+            </a:r>
+          </a:p>
+          <a:p>
+            <a:pPr>
+              <a:spcAft>
+                <a:spcPts val="1000"/>
+              </a:spcAft>
+            </a:pPr>
+            <a:r>
+              <a:rPr sz="1800" b="0">
+                <a:solidFill>
+                  <a:srgbClr val="2C3E50"/>
+                </a:solidFill>
+                <a:latin typeface="Calibri"/>
+              </a:rPr>
+              <a:t>• Contra un backend real los ms suben → el número del umbral es decisión de negocio</a:t>
             </a:r>
           </a:p>
           <a:p>
@@ -3617,7 +3665,7 @@
                 </a:solidFill>
                 <a:latin typeface="Calibri"/>
               </a:rPr>
-              <a:t>Cómo leer (sin miedo)</a:t>
+              <a:t>El resumen es largo — mira solo 4 líneas</a:t>
             </a:r>
           </a:p>
         </p:txBody>
@@ -3690,23 +3738,7 @@
                 </a:solidFill>
                 <a:latin typeface="Calibri"/>
               </a:rPr>
-              <a:t>• Solo 4 cosas: duration · failed · checks · ✓/✗ thresholds</a:t>
-            </a:r>
-          </a:p>
-          <a:p>
-            <a:pPr>
-              <a:spcAft>
-                <a:spcPts val="1000"/>
-              </a:spcAft>
-            </a:pPr>
-            <a:r>
-              <a:rPr sz="1800" b="0">
-                <a:solidFill>
-                  <a:srgbClr val="2C3E50"/>
-                </a:solidFill>
-                <a:latin typeface="Calibri"/>
-              </a:rPr>
-              <a:t>• Si no sabes leerlo, no vas a saber por qué CI se puso rojo</a:t>
+              <a:t>• Si no sabes leer estas 4, el rojo de CI es superstición</a:t>
             </a:r>
           </a:p>
         </p:txBody>
@@ -3836,7 +3868,7 @@
                 </a:solidFill>
                 <a:latin typeface="Calibri"/>
               </a:rPr>
-              <a:t>DEMO del fallo (rojo)</a:t>
+              <a:t>El aha — checks verdes, gate rojo</a:t>
             </a:r>
           </a:p>
         </p:txBody>
@@ -3909,7 +3941,7 @@
                 </a:solidFill>
                 <a:latin typeface="Calibri"/>
               </a:rPr>
-              <a:t>• p95 &lt; 1ms → imposible → exit ≠ 0 (99)</a:t>
+              <a:t>• El check no mueve el gate; el threshold sí</a:t>
             </a:r>
           </a:p>
           <a:p>
@@ -3925,7 +3957,7 @@
                 </a:solidFill>
                 <a:latin typeface="Calibri"/>
               </a:rPr>
-              <a:t>• “Así se bloquea un merge”</a:t>
+              <a:t>• En un pipeline: exit 99 = "no" al merge</a:t>
             </a:r>
           </a:p>
           <a:p>
@@ -3941,7 +3973,7 @@
                 </a:solidFill>
                 <a:latin typeface="Calibri"/>
               </a:rPr>
-              <a:t>• Código: docker compose run --rm k6-fail</a:t>
+              <a:t>• Código: thresholds: { http_req_duration: ["p(95)&lt;1"] }  // imposible | checks_succeeded: 100% (98/98)     ← todos verdes | ✗ 'p(95)&lt;1' p(95)≈14ms             ← threshold roto → exit 99</a:t>
             </a:r>
           </a:p>
         </p:txBody>
@@ -4071,7 +4103,7 @@
                 </a:solidFill>
                 <a:latin typeface="Calibri"/>
               </a:rPr>
-              <a:t>K6 en el pipeline</a:t>
+              <a:t>Mismo criterio que la S5 + baseline</a:t>
             </a:r>
           </a:p>
         </p:txBody>
@@ -4144,7 +4176,7 @@
                 </a:solidFill>
                 <a:latin typeface="Calibri"/>
               </a:rPr>
-              <a:t>• Smoke/pytest en PR · load más pesado de noche / en main</a:t>
+              <a:t>• Smoke en PR (rápido) · load en main / noche (concepto)</a:t>
             </a:r>
           </a:p>
           <a:p>
@@ -4160,7 +4192,39 @@
                 </a:solidFill>
                 <a:latin typeface="Calibri"/>
               </a:rPr>
-              <a:t>• Mismo criterio: código de salida (S5)</a:t>
+              <a:t>• Plantilla: performance/workflows/qa-perf.yml</a:t>
+            </a:r>
+          </a:p>
+          <a:p>
+            <a:pPr>
+              <a:spcAft>
+                <a:spcPts val="1000"/>
+              </a:spcAft>
+            </a:pPr>
+            <a:r>
+              <a:rPr sz="1800" b="0">
+                <a:solidFill>
+                  <a:srgbClr val="2C3E50"/>
+                </a:solidFill>
+                <a:latin typeface="Calibri"/>
+              </a:rPr>
+              <a:t>• Regla: baseline real + buffer 20–30% = umbral de gate</a:t>
+            </a:r>
+          </a:p>
+          <a:p>
+            <a:pPr>
+              <a:spcAft>
+                <a:spcPts val="1000"/>
+              </a:spcAft>
+            </a:pPr>
+            <a:r>
+              <a:rPr sz="1800" b="0">
+                <a:solidFill>
+                  <a:srgbClr val="2C3E50"/>
+                </a:solidFill>
+                <a:latin typeface="Calibri"/>
+              </a:rPr>
+              <a:t>• Hoy el criterio es el exit code, igual que pytest</a:t>
             </a:r>
           </a:p>
         </p:txBody>
@@ -4363,7 +4427,7 @@
                 </a:solidFill>
                 <a:latin typeface="Calibri"/>
               </a:rPr>
-              <a:t>• Ya viste verde y rojo de performance</a:t>
+              <a:t>• Corriste smoke y load en verde · provocaste exit 99</a:t>
             </a:r>
           </a:p>
           <a:p>
@@ -4379,7 +4443,23 @@
                 </a:solidFill>
                 <a:latin typeface="Calibri"/>
               </a:rPr>
-              <a:t>• Tras el café: endureces el umbral</a:t>
+              <a:t>• Entendiste check ≠ threshold</a:t>
+            </a:r>
+          </a:p>
+          <a:p>
+            <a:pPr>
+              <a:spcAft>
+                <a:spcPts val="1000"/>
+              </a:spcAft>
+            </a:pPr>
+            <a:r>
+              <a:rPr sz="1800" b="0">
+                <a:solidFill>
+                  <a:srgbClr val="2C3E50"/>
+                </a:solidFill>
+                <a:latin typeface="Calibri"/>
+              </a:rPr>
+              <a:t>• Tras el café: tú endureces el umbral</a:t>
             </a:r>
           </a:p>
         </p:txBody>
@@ -4509,7 +4589,7 @@
                 </a:solidFill>
                 <a:latin typeface="Calibri"/>
               </a:rPr>
-              <a:t>Mini-reto y cierre Reto 1</a:t>
+              <a:t>Mini-reto y cierre del Reto 1</a:t>
             </a:r>
           </a:p>
         </p:txBody>
@@ -4712,7 +4792,7 @@
                 </a:solidFill>
                 <a:latin typeface="Calibri"/>
               </a:rPr>
-              <a:t>Mini-reto</a:t>
+              <a:t>Mini-reto: endurece un threshold</a:t>
             </a:r>
           </a:p>
         </p:txBody>
@@ -4785,7 +4865,7 @@
                 </a:solidFill>
                 <a:latin typeface="Calibri"/>
               </a:rPr>
-              <a:t>• p(95)&lt;800 → &lt;5 · correr · ver rojo · revertir</a:t>
+              <a:t>• Subir/bajar ese número = decisión de negocio, no magia</a:t>
             </a:r>
           </a:p>
         </p:txBody>
@@ -4915,7 +4995,7 @@
                 </a:solidFill>
                 <a:latin typeface="Calibri"/>
               </a:rPr>
-              <a:t>JMeter / Gatling</a:t>
+              <a:t>p95 vs promedio</a:t>
             </a:r>
           </a:p>
         </p:txBody>
@@ -4988,7 +5068,7 @@
                 </a:solidFill>
                 <a:latin typeface="Calibri"/>
               </a:rPr>
-              <a:t>• Herramientas del mercado · patrón igual</a:t>
+              <a:t>• Métrica — Qué esconde</a:t>
             </a:r>
           </a:p>
           <a:p>
@@ -5004,7 +5084,55 @@
                 </a:solidFill>
                 <a:latin typeface="Calibri"/>
               </a:rPr>
-              <a:t>• K6 = nuestra ruta, integrada con CI</a:t>
+              <a:t>• Promedio — Un pico de 5 s se diluye → engaña</a:t>
+            </a:r>
+          </a:p>
+          <a:p>
+            <a:pPr>
+              <a:spcAft>
+                <a:spcPts val="1000"/>
+              </a:spcAft>
+            </a:pPr>
+            <a:r>
+              <a:rPr sz="1800" b="0">
+                <a:solidFill>
+                  <a:srgbClr val="2C3E50"/>
+                </a:solidFill>
+                <a:latin typeface="Calibri"/>
+              </a:rPr>
+              <a:t>• p95 / p99 — Cola lenta = usuario desafortunado</a:t>
+            </a:r>
+          </a:p>
+          <a:p>
+            <a:pPr>
+              <a:spcAft>
+                <a:spcPts val="1000"/>
+              </a:spcAft>
+            </a:pPr>
+            <a:r>
+              <a:rPr sz="1800" b="0">
+                <a:solidFill>
+                  <a:srgbClr val="2C3E50"/>
+                </a:solidFill>
+                <a:latin typeface="Calibri"/>
+              </a:rPr>
+              <a:t>• SLO/SLA se escriben con percentiles: "p95 &lt; 300 ms"</a:t>
+            </a:r>
+          </a:p>
+          <a:p>
+            <a:pPr>
+              <a:spcAft>
+                <a:spcPts val="1000"/>
+              </a:spcAft>
+            </a:pPr>
+            <a:r>
+              <a:rPr sz="1800" b="0">
+                <a:solidFill>
+                  <a:srgbClr val="2C3E50"/>
+                </a:solidFill>
+                <a:latin typeface="Calibri"/>
+              </a:rPr>
+              <a:t>• Mide la cola, no el centro</a:t>
             </a:r>
           </a:p>
         </p:txBody>
@@ -5134,7 +5262,7 @@
                 </a:solidFill>
                 <a:latin typeface="Calibri"/>
               </a:rPr>
-              <a:t>Reto 1 cerrado</a:t>
+              <a:t>Herramientas del mercado</a:t>
             </a:r>
           </a:p>
         </p:txBody>
@@ -5207,7 +5335,7 @@
                 </a:solidFill>
                 <a:latin typeface="Calibri"/>
               </a:rPr>
-              <a:t>• API automatizada + CI + K6 thresholds</a:t>
+              <a:t>• K6 — JS + CI — nuestra ruta</a:t>
             </a:r>
           </a:p>
           <a:p>
@@ -5223,7 +5351,55 @@
                 </a:solidFill>
                 <a:latin typeface="Calibri"/>
               </a:rPr>
-              <a:t>• Piezas S3–S6</a:t>
+              <a:t>• JMeter — GUI · legados</a:t>
+            </a:r>
+          </a:p>
+          <a:p>
+            <a:pPr>
+              <a:spcAft>
+                <a:spcPts val="1000"/>
+              </a:spcAft>
+            </a:pPr>
+            <a:r>
+              <a:rPr sz="1800" b="0">
+                <a:solidFill>
+                  <a:srgbClr val="2C3E50"/>
+                </a:solidFill>
+                <a:latin typeface="Calibri"/>
+              </a:rPr>
+              <a:t>• Gatling — JVM · reportes ricos</a:t>
+            </a:r>
+          </a:p>
+          <a:p>
+            <a:pPr>
+              <a:spcAft>
+                <a:spcPts val="1000"/>
+              </a:spcAft>
+            </a:pPr>
+            <a:r>
+              <a:rPr sz="1800" b="0">
+                <a:solidFill>
+                  <a:srgbClr val="2C3E50"/>
+                </a:solidFill>
+                <a:latin typeface="Calibri"/>
+              </a:rPr>
+              <a:t>• Locust — Python</a:t>
+            </a:r>
+          </a:p>
+          <a:p>
+            <a:pPr>
+              <a:spcAft>
+                <a:spcPts val="1000"/>
+              </a:spcAft>
+            </a:pPr>
+            <a:r>
+              <a:rPr sz="1800" b="0">
+                <a:solidFill>
+                  <a:srgbClr val="2C3E50"/>
+                </a:solidFill>
+                <a:latin typeface="Calibri"/>
+              </a:rPr>
+              <a:t>• Grafana Cloud k6: mismo script, miles de VUs</a:t>
             </a:r>
           </a:p>
         </p:txBody>
@@ -5353,7 +5529,7 @@
                 </a:solidFill>
                 <a:latin typeface="Calibri"/>
               </a:rPr>
-              <a:t>Checklist + frase de cierre</a:t>
+              <a:t>Reto 1 cerrado + checklist</a:t>
             </a:r>
           </a:p>
         </p:txBody>
@@ -5426,7 +5602,7 @@
                 </a:solidFill>
                 <a:latin typeface="Calibri"/>
               </a:rPr>
-              <a:t>• Checklist del SESION_06</a:t>
+              <a:t>• API (S3/S4) + CI (S5) + umbrales K6 (hoy)</a:t>
             </a:r>
           </a:p>
           <a:p>
@@ -5442,7 +5618,7 @@
                 </a:solidFill>
                 <a:latin typeface="Calibri"/>
               </a:rPr>
-              <a:t>• Completa: “Un threshold sirve para ___.”</a:t>
+              <a:t>• Checklist:</a:t>
             </a:r>
           </a:p>
         </p:txBody>
@@ -5572,7 +5748,7 @@
                 </a:solidFill>
                 <a:latin typeface="Calibri"/>
               </a:rPr>
-              <a:t>Al salir vas a poder</a:t>
+              <a:t>¿Dónde estamos?</a:t>
             </a:r>
           </a:p>
         </p:txBody>
@@ -5645,7 +5821,7 @@
                 </a:solidFill>
                 <a:latin typeface="Calibri"/>
               </a:rPr>
-              <a:t>• Smoke / load / thresholds</a:t>
+              <a:t>• S3/S4 ✅ La API responde lo correcto</a:t>
             </a:r>
           </a:p>
           <a:p>
@@ -5661,7 +5837,7 @@
                 </a:solidFill>
                 <a:latin typeface="Calibri"/>
               </a:rPr>
-              <a:t>• Correr K6 en Docker (imagen 1.8)</a:t>
+              <a:t>• S5 ✅ CI corre esos tests solo, en cada push</a:t>
             </a:r>
           </a:p>
           <a:p>
@@ -5677,7 +5853,7 @@
                 </a:solidFill>
                 <a:latin typeface="Calibri"/>
               </a:rPr>
-              <a:t>• Provocar un fallo (rojo) a propósito</a:t>
+              <a:t>• S6 → La pregunta que falta: ¿aguanta bajo carga?</a:t>
             </a:r>
           </a:p>
           <a:p>
@@ -5693,7 +5869,7 @@
                 </a:solidFill>
                 <a:latin typeface="Calibri"/>
               </a:rPr>
-              <a:t>• Cerrar Reto 1 (concepto): API + CI + umbrales</a:t>
+              <a:t>• Una API correcta que tarda 3 s con 100 usuarios está, en la práctica, caída</a:t>
             </a:r>
           </a:p>
         </p:txBody>
@@ -5823,7 +5999,7 @@
                 </a:solidFill>
                 <a:latin typeface="Calibri"/>
               </a:rPr>
-              <a:t>Gracias</a:t>
+              <a:t>Errores + frase de cierre</a:t>
             </a:r>
           </a:p>
         </p:txBody>
@@ -5896,7 +6072,7 @@
                 </a:solidFill>
                 <a:latin typeface="Calibri"/>
               </a:rPr>
-              <a:t>• proyecto-integrador/performance/</a:t>
+              <a:t>• 8080 ocupado · target vs localhost · pull lento de k6 · no revertir el mini-reto</a:t>
             </a:r>
           </a:p>
           <a:p>
@@ -5912,7 +6088,23 @@
                 </a:solidFill>
                 <a:latin typeface="Calibri"/>
               </a:rPr>
-              <a:t>• Próxima: Seguridad (S7)</a:t>
+              <a:t>• Completa: *"Un threshold sirve para ___."*</a:t>
+            </a:r>
+          </a:p>
+          <a:p>
+            <a:pPr>
+              <a:spcAft>
+                <a:spcPts val="1000"/>
+              </a:spcAft>
+            </a:pPr>
+            <a:r>
+              <a:rPr sz="1800" b="0">
+                <a:solidFill>
+                  <a:srgbClr val="2C3E50"/>
+                </a:solidFill>
+                <a:latin typeface="Calibri"/>
+              </a:rPr>
+              <a:t>• S7: Seguridad — el mismo criterio automático, ahora contra vulnerabilidades</a:t>
             </a:r>
           </a:p>
         </p:txBody>
@@ -6042,7 +6234,7 @@
                 </a:solidFill>
                 <a:latin typeface="Calibri"/>
               </a:rPr>
-              <a:t>Funcional vs performance</a:t>
+              <a:t>Dos preguntas distintas sobre el mismo endpoint</a:t>
             </a:r>
           </a:p>
         </p:txBody>
@@ -6115,7 +6307,7 @@
                 </a:solidFill>
                 <a:latin typeface="Calibri"/>
               </a:rPr>
-              <a:t>• Correcto ≠ usable bajo carga</a:t>
+              <a:t>• Tipo — Pregunta — Cómo falla</a:t>
             </a:r>
           </a:p>
           <a:p>
@@ -6131,7 +6323,55 @@
                 </a:solidFill>
                 <a:latin typeface="Calibri"/>
               </a:rPr>
-              <a:t>• Complementa al test funcional; no lo reemplaza</a:t>
+              <a:t>• Funcional — ¿Resultado correcto? — assert / check</a:t>
+            </a:r>
+          </a:p>
+          <a:p>
+            <a:pPr>
+              <a:spcAft>
+                <a:spcPts val="1000"/>
+              </a:spcAft>
+            </a:pPr>
+            <a:r>
+              <a:rPr sz="1800" b="0">
+                <a:solidFill>
+                  <a:srgbClr val="2C3E50"/>
+                </a:solidFill>
+                <a:latin typeface="Calibri"/>
+              </a:rPr>
+              <a:t>• Performance — ¿Rápido y estable bajo carga? — threshold roto</a:t>
+            </a:r>
+          </a:p>
+          <a:p>
+            <a:pPr>
+              <a:spcAft>
+                <a:spcPts val="1000"/>
+              </a:spcAft>
+            </a:pPr>
+            <a:r>
+              <a:rPr sz="1800" b="0">
+                <a:solidFill>
+                  <a:srgbClr val="2C3E50"/>
+                </a:solidFill>
+                <a:latin typeface="Calibri"/>
+              </a:rPr>
+              <a:t>• Ejemplo: GET /checkout OK… en 3.4 s con 200 usuarios → nadie compra</a:t>
+            </a:r>
+          </a:p>
+          <a:p>
+            <a:pPr>
+              <a:spcAft>
+                <a:spcPts val="1000"/>
+              </a:spcAft>
+            </a:pPr>
+            <a:r>
+              <a:rPr sz="1800" b="0">
+                <a:solidFill>
+                  <a:srgbClr val="2C3E50"/>
+                </a:solidFill>
+                <a:latin typeface="Calibri"/>
+              </a:rPr>
+              <a:t>• Performance complementa; no reemplaza</a:t>
             </a:r>
           </a:p>
         </p:txBody>
@@ -6261,7 +6501,7 @@
                 </a:solidFill>
                 <a:latin typeface="Calibri"/>
               </a:rPr>
-              <a:t>Vocabulario corto</a:t>
+              <a:t>Los términos que vas a leer en cada reporte</a:t>
             </a:r>
           </a:p>
         </p:txBody>
@@ -6334,7 +6574,7 @@
                 </a:solidFill>
                 <a:latin typeface="Calibri"/>
               </a:rPr>
-              <a:t>• VU · p95 · error rate</a:t>
+              <a:t>• VU — Usuario virtual</a:t>
             </a:r>
           </a:p>
           <a:p>
@@ -6350,7 +6590,7 @@
                 </a:solidFill>
                 <a:latin typeface="Calibri"/>
               </a:rPr>
-              <a:t>• Check ≠ threshold (el pipeline escucha el threshold)</a:t>
+              <a:t>• p95 — Cola lenta (no el promedio)</a:t>
             </a:r>
           </a:p>
           <a:p>
@@ -6366,7 +6606,7 @@
                 </a:solidFill>
                 <a:latin typeface="Calibri"/>
               </a:rPr>
-              <a:t>• Smoke / load</a:t>
+              <a:t>• Check — Assert por request — no cambia el exit code solo</a:t>
             </a:r>
           </a:p>
           <a:p>
@@ -6382,7 +6622,55 @@
                 </a:solidFill>
                 <a:latin typeface="Calibri"/>
               </a:rPr>
-              <a:t>• Pausa 20 s: ¿son lo mismo check y threshold?</a:t>
+              <a:t>• Threshold — Criterio global → si se rompe, exit 99</a:t>
+            </a:r>
+          </a:p>
+          <a:p>
+            <a:pPr>
+              <a:spcAft>
+                <a:spcPts val="1000"/>
+              </a:spcAft>
+            </a:pPr>
+            <a:r>
+              <a:rPr sz="1800" b="0">
+                <a:solidFill>
+                  <a:srgbClr val="2C3E50"/>
+                </a:solidFill>
+                <a:latin typeface="Calibri"/>
+              </a:rPr>
+              <a:t>• Think time — sleep entre requests (humano real)</a:t>
+            </a:r>
+          </a:p>
+          <a:p>
+            <a:pPr>
+              <a:spcAft>
+                <a:spcPts val="1000"/>
+              </a:spcAft>
+            </a:pPr>
+            <a:r>
+              <a:rPr sz="1800" b="0">
+                <a:solidFill>
+                  <a:srgbClr val="2C3E50"/>
+                </a:solidFill>
+                <a:latin typeface="Calibri"/>
+              </a:rPr>
+              <a:t>• Distinción del día: CI escucha el threshold, no el check</a:t>
+            </a:r>
+          </a:p>
+          <a:p>
+            <a:pPr>
+              <a:spcAft>
+                <a:spcPts val="1000"/>
+              </a:spcAft>
+            </a:pPr>
+            <a:r>
+              <a:rPr sz="1800" b="0">
+                <a:solidFill>
+                  <a:srgbClr val="2C3E50"/>
+                </a:solidFill>
+                <a:latin typeface="Calibri"/>
+              </a:rPr>
+              <a:t>• Mapa rápido: smoke / load (hoy) · stress / spike (concepto)</a:t>
             </a:r>
           </a:p>
         </p:txBody>
@@ -6512,7 +6800,7 @@
                 </a:solidFill>
                 <a:latin typeface="Calibri"/>
               </a:rPr>
-              <a:t>K6 como código 2026</a:t>
+              <a:t>El script vive en Git y corre en Docker</a:t>
             </a:r>
           </a:p>
         </p:txBody>
@@ -6585,7 +6873,7 @@
                 </a:solidFill>
                 <a:latin typeface="Calibri"/>
               </a:rPr>
-              <a:t>• JS en Git · corre en CI</a:t>
+              <a:t>• JS en PR · imagen grafana/k6:1.8.0 · no instalas K6</a:t>
             </a:r>
           </a:p>
           <a:p>
@@ -6601,7 +6889,7 @@
                 </a:solidFill>
                 <a:latin typeface="Calibri"/>
               </a:rPr>
-              <a:t>• scenarios + ramping-vus</a:t>
+              <a:t>• Mercado: K6 (nuestra ruta) · JMeter · Gatling · Locust — mismo patrón</a:t>
             </a:r>
           </a:p>
           <a:p>
@@ -6617,7 +6905,7 @@
                 </a:solidFill>
                 <a:latin typeface="Calibri"/>
               </a:rPr>
-              <a:t>• Imagen grafana/k6:1.8.0</a:t>
+              <a:t>• Escala (concepto): Grafana Cloud k6 = mismo script, miles de VUs</a:t>
             </a:r>
           </a:p>
           <a:p>
@@ -6633,7 +6921,7 @@
                 </a:solidFill>
                 <a:latin typeface="Calibri"/>
               </a:rPr>
-              <a:t>• Escala (concepto): Grafana Cloud k6</a:t>
+              <a:t>• Código: export const options = { |   vus: 2, duration: "15s", |   thresholds: { http_req_duration: ["p(95)&lt;500"] },  // gate | }; | export default function () {</a:t>
             </a:r>
           </a:p>
         </p:txBody>
@@ -6763,7 +7051,7 @@
                 </a:solidFill>
                 <a:latin typeface="Calibri"/>
               </a:rPr>
-              <a:t>Target local</a:t>
+              <a:t>Qué vamos a golpear hoy</a:t>
             </a:r>
           </a:p>
         </p:txBody>
@@ -6836,7 +7124,7 @@
                 </a:solidFill>
                 <a:latin typeface="Calibri"/>
               </a:rPr>
-              <a:t>• nginx · :8080 · /api/health</a:t>
+              <a:t>• GET /api/health → {"status":"ok"} · GET /api/product → producto con title</a:t>
             </a:r>
           </a:p>
           <a:p>
@@ -6852,7 +7140,39 @@
                 </a:solidFill>
                 <a:latin typeface="Calibri"/>
               </a:rPr>
-              <a:t>• Sin internet en el camino feliz</a:t>
+              <a:t>• K6 pega a http://target:8080 (red Docker), no localhost</a:t>
+            </a:r>
+          </a:p>
+          <a:p>
+            <a:pPr>
+              <a:spcAft>
+                <a:spcPts val="1000"/>
+              </a:spcAft>
+            </a:pPr>
+            <a:r>
+              <a:rPr sz="1800" b="0">
+                <a:solidFill>
+                  <a:srgbClr val="2C3E50"/>
+                </a:solidFill>
+                <a:latin typeface="Calibri"/>
+              </a:rPr>
+              <a:t>• Compose espera healthy antes de lanzar K6</a:t>
+            </a:r>
+          </a:p>
+          <a:p>
+            <a:pPr>
+              <a:spcAft>
+                <a:spcPts val="1000"/>
+              </a:spcAft>
+            </a:pPr>
+            <a:r>
+              <a:rPr sz="1800" b="0">
+                <a:solidFill>
+                  <a:srgbClr val="2C3E50"/>
+                </a:solidFill>
+                <a:latin typeface="Calibri"/>
+              </a:rPr>
+              <a:t>• Camino feliz reproducible sin internet</a:t>
             </a:r>
           </a:p>
         </p:txBody>
@@ -6982,7 +7302,7 @@
                 </a:solidFill>
                 <a:latin typeface="Calibri"/>
               </a:rPr>
-              <a:t>DEMO smoke</a:t>
+              <a:t>Primera corrida — ¿enciende?</a:t>
             </a:r>
           </a:p>
         </p:txBody>
@@ -7055,7 +7375,7 @@
                 </a:solidFill>
                 <a:latin typeface="Calibri"/>
               </a:rPr>
-              <a:t>• Predicción → Enter → exit 0</a:t>
+              <a:t>• Predicción antes de Enter: ¿exit 0 o ≠ 0?</a:t>
             </a:r>
           </a:p>
           <a:p>
@@ -7071,7 +7391,7 @@
                 </a:solidFill>
                 <a:latin typeface="Calibri"/>
               </a:rPr>
-              <a:t>• Abre smoke.js: options + thresholds + checks</a:t>
+              <a:t>• Resultado real: ✓ p(95)&lt;500 (~49 ms) · checks 100% · exit 0</a:t>
             </a:r>
           </a:p>
           <a:p>
@@ -7087,7 +7407,23 @@
                 </a:solidFill>
                 <a:latin typeface="Calibri"/>
               </a:rPr>
-              <a:t>• Tras el café: load</a:t>
+              <a:t>• Abre smoke.js: options + default function + sleep</a:t>
+            </a:r>
+          </a:p>
+          <a:p>
+            <a:pPr>
+              <a:spcAft>
+                <a:spcPts val="1000"/>
+              </a:spcAft>
+            </a:pPr>
+            <a:r>
+              <a:rPr sz="1800" b="0">
+                <a:solidFill>
+                  <a:srgbClr val="2C3E50"/>
+                </a:solidFill>
+                <a:latin typeface="Calibri"/>
+              </a:rPr>
+              <a:t>• Café → load con etapas</a:t>
             </a:r>
           </a:p>
           <a:p>
@@ -7233,7 +7569,7 @@
                 </a:solidFill>
                 <a:latin typeface="Calibri"/>
               </a:rPr>
-              <a:t>Load + el fallo (rojo)</a:t>
+              <a:t>De "enciende" a "aguanta"</a:t>
             </a:r>
           </a:p>
         </p:txBody>
@@ -7306,7 +7642,7 @@
                 </a:solidFill>
                 <a:latin typeface="Calibri"/>
               </a:rPr>
-              <a:t>• Ver guía del instructor / SESION_0X.md</a:t>
+              <a:t>• Smoke = ¿responde? · Load = ¿aguanta con etapas?</a:t>
             </a:r>
           </a:p>
         </p:txBody>
@@ -7436,7 +7772,7 @@
                 </a:solidFill>
                 <a:latin typeface="Calibri"/>
               </a:rPr>
-              <a:t>Stages / ramping-vus</a:t>
+              <a:t>Sube, mantiene, baja</a:t>
             </a:r>
           </a:p>
         </p:txBody>
@@ -7509,7 +7845,7 @@
                 </a:solidFill>
                 <a:latin typeface="Calibri"/>
               </a:rPr>
-              <a:t>• Subir → mantener → bajar</a:t>
+              <a:t>• Misma historia que smoke: health + product + think time</a:t>
             </a:r>
           </a:p>
           <a:p>
@@ -7525,7 +7861,23 @@
                 </a:solidFill>
                 <a:latin typeface="Calibri"/>
               </a:rPr>
-              <a:t>• Archivo: load.js · escenario average_load</a:t>
+              <a:t>• Estilo moderno k6 1.x: scenarios + ramping-vus</a:t>
+            </a:r>
+          </a:p>
+          <a:p>
+            <a:pPr>
+              <a:spcAft>
+                <a:spcPts val="1000"/>
+              </a:spcAft>
+            </a:pPr>
+            <a:r>
+              <a:rPr sz="1800" b="0">
+                <a:solidFill>
+                  <a:srgbClr val="2C3E50"/>
+                </a:solidFill>
+                <a:latin typeface="Calibri"/>
+              </a:rPr>
+              <a:t>• Código: scenarios: { |   average_load: { |     executor: "ramping-vus", |     stages: [ |       { duration: "10s", target: 5 },</a:t>
             </a:r>
           </a:p>
         </p:txBody>

</xml_diff>